<commit_message>
Update presentation materials and outlines for evidence learning
- Modified multiple PowerPoint presentations for various topics including failure improvement, free tier, judgment, product engineering, and retrieval, ensuring all files are updated with the latest content.
- Updated sync-inputs.json with new SHA256 hashes for several outlines and added new entries for evidence learning.
- Adjusted timing and content in the evidence learning outline and scripts to improve flow and clarity, including changes to slide timings and descriptions.
- Fixed issues in the audit for evidence learning, addressing blocking items and ensuring all changes are verified and documented.
</commit_message>
<xml_diff>
--- a/artifacts/speaking-portfolio-expanded/decks/adaptive-systems-15min-handout.pptx
+++ b/artifacts/speaking-portfolio-expanded/decks/adaptive-systems-15min-handout.pptx
@@ -2899,7 +2899,7 @@
                 <a:ea typeface="Arial"/>
                 <a:cs typeface="Arial"/>
               </a:rPr>
-              <a:t xml:space="preserve">Zoom out from the ingest job. The assistant with every customer's data and a toolbox that can send email, issue refunds, delete records and ship code is not a design we get to decline. It is arriving one integration at a time, and not only in our products. Browsers now ship a chat that drives the page. WebMCP lets an agent act on whatever site you have open. The next generation of CLIs will take natural language by default, and you will pass `--no-agent` to get the old behavior back. The intermediary intelligence layer is going to wrap everything, and I know who to blame: the kids. Actually, the kids hate AI. It will be their kids who demand an agent safety blanket on everything. I will be in a rocking chair explaining that the internet was better on vinyl.</a:t>
+              <a:t xml:space="preserve">Zoom out from the ingest job. The assistant with every customer's data and a toolbox that can send email, issue refunds, delete records and ship code is not a design we get to decline. It is arriving one integration at a time, and not only in our products. Browsers now ship a chat that drives the page. WebMCP lets an agent act on any site that opts in, and the list of sites that opt in only goes one direction. The next generation of CLIs will take natural language by default, and you will pass `--no-agent` to get the old behavior back. The intermediary intelligence layer is going to wrap everything, and I know who to blame: the kids. Actually, the kids hate AI. It will be their kids who demand an agent safety blanket on everything. I will be in a rocking chair explaining that the internet was better on vinyl.</a:t>
             </a:r>
             <a:endParaRPr lang="en-US" sz="1200"/>
           </a:p>
@@ -3426,7 +3426,7 @@
                 <a:ea typeface="Arial"/>
                 <a:cs typeface="Arial"/>
               </a:rPr>
-              <a:t xml:space="preserve">Zoom out from the ingest job. The assistant with every customer's data and a toolbox that can send email, issue refunds, delete records and ship code is not a design we get to decline. It is arriving one integration at a time, and not only in our products. Browsers now ship a chat that drives the page. WebMCP lets an agent act on whatever site you have open. The next generation of CLIs will take natural language by default, and you will pass `--no-agent` to get the old behavior back. The intermediary intelligence layer is going to wrap everything, and I know who to blame: the kids. Actually, the kids hate AI. It will be their kids who demand an agent safety blanket on everything. I will be in a rocking chair explaining that the internet was better on vinyl.</a:t>
+              <a:t xml:space="preserve">Zoom out from the ingest job. The assistant with every customer's data and a toolbox that can send email, issue refunds, delete records and ship code is not a design we get to decline. It is arriving one integration at a time, and not only in our products. Browsers now ship a chat that drives the page. WebMCP lets an agent act on any site that opts in, and the list of sites that opt in only goes one direction. The next generation of CLIs will take natural language by default, and you will pass `--no-agent` to get the old behavior back. The intermediary intelligence layer is going to wrap everything, and I know who to blame: the kids. Actually, the kids hate AI. It will be their kids who demand an agent safety blanket on everything. I will be in a rocking chair explaining that the internet was better on vinyl.</a:t>
             </a:r>
             <a:endParaRPr lang="en-US" sz="1200"/>
           </a:p>
@@ -4388,7 +4388,7 @@
                 <a:ea typeface="Arial"/>
                 <a:cs typeface="Arial"/>
               </a:rPr>
-              <a:t xml:space="preserve">Read customer data and post to a vendor never share one agent</a:t>
+              <a:t xml:space="preserve">Reads customer data? Then it never posts to a vendor.</a:t>
             </a:r>
             <a:endParaRPr lang="en-US" sz="1200"/>
           </a:p>
@@ -5007,7 +5007,7 @@
                 <a:ea typeface="Arial"/>
                 <a:cs typeface="Arial"/>
               </a:rPr>
-              <a:t xml:space="preserve">Read customer data and post to a vendor never share one agent</a:t>
+              <a:t xml:space="preserve">Reads customer data? Then it never posts to a vendor.</a:t>
             </a:r>
             <a:endParaRPr lang="en-US" sz="1200"/>
           </a:p>
@@ -6337,6 +6337,52 @@
                 <a:ea typeface="Arial"/>
                 <a:cs typeface="Arial"/>
               </a:rPr>
+              <a:t xml:space="preserve">Three events, three different right answers, none of them success or failure. If your dashboard only has two states, it is hiding the most interesting one.</a:t>
+            </a:r>
+            <a:endParaRPr lang="en-US" sz="1200"/>
+          </a:p>
+          <a:p>
+            <a:pPr marL="0" indent="0">
+              <a:lnSpc>
+                <a:spcPts val="1560"/>
+              </a:lnSpc>
+              <a:spcAft>
+                <a:spcPts val="0"/>
+              </a:spcAft>
+              <a:buNone/>
+            </a:pPr>
+            <a:r>
+              <a:rPr lang="en-US" sz="1200" b="0">
+                <a:solidFill>
+                  <a:srgbClr val="202b33"/>
+                </a:solidFill>
+                <a:latin typeface="Arial"/>
+                <a:ea typeface="Arial"/>
+                <a:cs typeface="Arial"/>
+              </a:rPr>
+              <a:t xml:space="preserve"/>
+            </a:r>
+            <a:endParaRPr lang="en-US" sz="1200"/>
+          </a:p>
+          <a:p>
+            <a:pPr marL="0" indent="0">
+              <a:lnSpc>
+                <a:spcPts val="1560"/>
+              </a:lnSpc>
+              <a:spcAft>
+                <a:spcPts val="0"/>
+              </a:spcAft>
+              <a:buNone/>
+            </a:pPr>
+            <a:r>
+              <a:rPr lang="en-US" sz="1200" b="0">
+                <a:solidFill>
+                  <a:srgbClr val="202b33"/>
+                </a:solidFill>
+                <a:latin typeface="Arial"/>
+                <a:ea typeface="Arial"/>
+                <a:cs typeface="Arial"/>
+              </a:rPr>
               <a:t xml:space="preserve"/>
             </a:r>
             <a:endParaRPr lang="en-US" sz="1200"/>
@@ -6429,7 +6475,7 @@
                 <a:ea typeface="Arial"/>
                 <a:cs typeface="Arial"/>
               </a:rPr>
-              <a:t xml:space="preserve">Bridge: the same orchestrator can ask for its own scale inside a per-customer budget; that is a companion talk.</a:t>
+              <a:t xml:space="preserve">Bridge: the same orchestrator can ask for its own scale inside a per-customer budget; that is slide 11 in the long version, and the mechanics are a companion talk.</a:t>
             </a:r>
             <a:endParaRPr lang="en-US" sz="1200"/>
           </a:p>
@@ -11209,30 +11255,7 @@
                 <a:ea typeface="Arial"/>
                 <a:cs typeface="Arial"/>
               </a:rPr>
-              <a:t xml:space="preserve">The assistant with everything is coming, one</a:t>
-            </a:r>
-            <a:endParaRPr lang="en-US" sz="2550"/>
-          </a:p>
-          <a:p>
-            <a:pPr marL="0" indent="0">
-              <a:lnSpc>
-                <a:spcPts val="3060"/>
-              </a:lnSpc>
-              <a:spcAft>
-                <a:spcPts val="0"/>
-              </a:spcAft>
-              <a:buNone/>
-            </a:pPr>
-            <a:r>
-              <a:rPr lang="en-US" sz="2550" b="1">
-                <a:solidFill>
-                  <a:srgbClr val="202B33"/>
-                </a:solidFill>
-                <a:latin typeface="Arial"/>
-                <a:ea typeface="Arial"/>
-                <a:cs typeface="Arial"/>
-              </a:rPr>
-              <a:t xml:space="preserve">integration at a time</a:t>
+              <a:t xml:space="preserve">Sorry, You're Building It</a:t>
             </a:r>
             <a:endParaRPr lang="en-US" sz="2550"/>
           </a:p>
@@ -11684,7 +11707,7 @@
                 <a:ea typeface="Arial"/>
                 <a:cs typeface="Arial"/>
               </a:rPr>
-              <a:t xml:space="preserve">lets an agent act on whatever site you have open. The</a:t>
+              <a:t xml:space="preserve">lets an agent act on any site that opts in, and the</a:t>
             </a:r>
             <a:endParaRPr lang="en-US" sz="1200"/>
           </a:p>
@@ -11707,7 +11730,7 @@
                 <a:ea typeface="Arial"/>
                 <a:cs typeface="Arial"/>
               </a:rPr>
-              <a:t xml:space="preserve">next generation of CLIs will take natural language by</a:t>
+              <a:t xml:space="preserve">list of sites that opt in only goes one direction.</a:t>
             </a:r>
             <a:endParaRPr lang="en-US" sz="1200"/>
           </a:p>
@@ -11730,7 +11753,7 @@
                 <a:ea typeface="Arial"/>
                 <a:cs typeface="Arial"/>
               </a:rPr>
-              <a:t xml:space="preserve">default, and you will pass --no-agent to get the old</a:t>
+              <a:t xml:space="preserve">The next generation of CLIs will take natural</a:t>
             </a:r>
             <a:endParaRPr lang="en-US" sz="1200"/>
           </a:p>
@@ -11753,7 +11776,7 @@
                 <a:ea typeface="Arial"/>
                 <a:cs typeface="Arial"/>
               </a:rPr>
-              <a:t xml:space="preserve">behavior back. The intermediary intelligence layer is</a:t>
+              <a:t xml:space="preserve">language by default, and you will pass --no-agent to</a:t>
             </a:r>
             <a:endParaRPr lang="en-US" sz="1200"/>
           </a:p>
@@ -11776,7 +11799,7 @@
                 <a:ea typeface="Arial"/>
                 <a:cs typeface="Arial"/>
               </a:rPr>
-              <a:t xml:space="preserve">going to wrap everything, and I know who to blame:</a:t>
+              <a:t xml:space="preserve">get the old behavior back. The intermediary</a:t>
             </a:r>
             <a:endParaRPr lang="en-US" sz="1200"/>
           </a:p>
@@ -11799,7 +11822,7 @@
                 <a:ea typeface="Arial"/>
                 <a:cs typeface="Arial"/>
               </a:rPr>
-              <a:t xml:space="preserve">the kids. Actually, the kids hate AI. It will be</a:t>
+              <a:t xml:space="preserve">intelligence layer is going to wrap everything, and I</a:t>
             </a:r>
             <a:endParaRPr lang="en-US" sz="1200"/>
           </a:p>
@@ -11822,7 +11845,7 @@
                 <a:ea typeface="Arial"/>
                 <a:cs typeface="Arial"/>
               </a:rPr>
-              <a:t xml:space="preserve">their kids who demand an agent safety blanket on</a:t>
+              <a:t xml:space="preserve">know who to blame: the kids. Actually, the kids hate</a:t>
             </a:r>
             <a:endParaRPr lang="en-US" sz="1200"/>
           </a:p>
@@ -11845,7 +11868,7 @@
                 <a:ea typeface="Arial"/>
                 <a:cs typeface="Arial"/>
               </a:rPr>
-              <a:t xml:space="preserve">everything. I will be in a rocking chair explaining</a:t>
+              <a:t xml:space="preserve">AI. It will be their kids who demand an agent safety</a:t>
             </a:r>
             <a:endParaRPr lang="en-US" sz="1200"/>
           </a:p>
@@ -11868,7 +11891,30 @@
                 <a:ea typeface="Arial"/>
                 <a:cs typeface="Arial"/>
               </a:rPr>
-              <a:t xml:space="preserve">that the internet was better on vinyl.</a:t>
+              <a:t xml:space="preserve">blanket on everything. I will be in a rocking chair</a:t>
+            </a:r>
+            <a:endParaRPr lang="en-US" sz="1200"/>
+          </a:p>
+          <a:p>
+            <a:pPr marL="0" indent="0">
+              <a:lnSpc>
+                <a:spcPts val="1575"/>
+              </a:lnSpc>
+              <a:spcAft>
+                <a:spcPts val="0"/>
+              </a:spcAft>
+              <a:buNone/>
+            </a:pPr>
+            <a:r>
+              <a:rPr lang="en-US" sz="1200" b="0">
+                <a:solidFill>
+                  <a:srgbClr val="202B33"/>
+                </a:solidFill>
+                <a:latin typeface="Arial"/>
+                <a:ea typeface="Arial"/>
+                <a:cs typeface="Arial"/>
+              </a:rPr>
+              <a:t xml:space="preserve">explaining that the internet was better on vinyl.</a:t>
             </a:r>
             <a:endParaRPr lang="en-US" sz="1200"/>
           </a:p>
@@ -12097,30 +12143,7 @@
                 <a:ea typeface="Arial"/>
                 <a:cs typeface="Arial"/>
               </a:rPr>
-              <a:t xml:space="preserve">The assistant with everything is coming, one</a:t>
-            </a:r>
-            <a:endParaRPr lang="en-US" sz="2550"/>
-          </a:p>
-          <a:p>
-            <a:pPr marL="0" indent="0">
-              <a:lnSpc>
-                <a:spcPts val="3060"/>
-              </a:lnSpc>
-              <a:spcAft>
-                <a:spcPts val="0"/>
-              </a:spcAft>
-              <a:buNone/>
-            </a:pPr>
-            <a:r>
-              <a:rPr lang="en-US" sz="2550" b="1">
-                <a:solidFill>
-                  <a:srgbClr val="202B33"/>
-                </a:solidFill>
-                <a:latin typeface="Arial"/>
-                <a:ea typeface="Arial"/>
-                <a:cs typeface="Arial"/>
-              </a:rPr>
-              <a:t xml:space="preserve">integration at a time (continued)</a:t>
+              <a:t xml:space="preserve">Sorry, You're Building It (continued)</a:t>
             </a:r>
             <a:endParaRPr lang="en-US" sz="2550"/>
           </a:p>
@@ -14060,7 +14083,7 @@
                 <a:ea typeface="Arial"/>
                 <a:cs typeface="Arial"/>
               </a:rPr>
-              <a:t xml:space="preserve">Read customer data and post to a vendor never share</a:t>
+              <a:t xml:space="preserve">Reads customer data? Then it never posts to a vendor.</a:t>
             </a:r>
             <a:endParaRPr lang="en-US" sz="1200"/>
           </a:p>
@@ -14083,7 +14106,7 @@
                 <a:ea typeface="Arial"/>
                 <a:cs typeface="Arial"/>
               </a:rPr>
-              <a:t xml:space="preserve">one agent</a:t>
+              <a:t xml:space="preserve"/>
             </a:r>
             <a:endParaRPr lang="en-US" sz="1200"/>
           </a:p>
@@ -14106,7 +14129,7 @@
                 <a:ea typeface="Arial"/>
                 <a:cs typeface="Arial"/>
               </a:rPr>
-              <a:t xml:space="preserve"/>
+              <a:t xml:space="preserve">A signed URL is a credential</a:t>
             </a:r>
             <a:endParaRPr lang="en-US" sz="1200"/>
           </a:p>
@@ -14129,7 +14152,7 @@
                 <a:ea typeface="Arial"/>
                 <a:cs typeface="Arial"/>
               </a:rPr>
-              <a:t xml:space="preserve">A signed URL is a credential</a:t>
+              <a:t xml:space="preserve"/>
             </a:r>
             <a:endParaRPr lang="en-US" sz="1200"/>
           </a:p>
@@ -14152,7 +14175,7 @@
                 <a:ea typeface="Arial"/>
                 <a:cs typeface="Arial"/>
               </a:rPr>
-              <a:t xml:space="preserve"/>
+              <a:t xml:space="preserve">Two guards do most of the work. First, tools come in</a:t>
             </a:r>
             <a:endParaRPr lang="en-US" sz="1200"/>
           </a:p>
@@ -14175,7 +14198,7 @@
                 <a:ea typeface="Arial"/>
                 <a:cs typeface="Arial"/>
               </a:rPr>
-              <a:t xml:space="preserve">Two guards do most of the work. First, tools come in</a:t>
+              <a:t xml:space="preserve">risk classes. Read is cheap to grant. Write, send,</a:t>
             </a:r>
             <a:endParaRPr lang="en-US" sz="1200"/>
           </a:p>
@@ -14198,7 +14221,7 @@
                 <a:ea typeface="Arial"/>
                 <a:cs typeface="Arial"/>
               </a:rPr>
-              <a:t xml:space="preserve">risk classes. Read is cheap to grant. Write, send,</a:t>
+              <a:t xml:space="preserve">pay, delete, deploy and export each need their own</a:t>
             </a:r>
             <a:endParaRPr lang="en-US" sz="1200"/>
           </a:p>
@@ -14221,7 +14244,7 @@
                 <a:ea typeface="Arial"/>
                 <a:cs typeface="Arial"/>
               </a:rPr>
-              <a:t xml:space="preserve">pay, delete, deploy and export each need their own</a:t>
+              <a:t xml:space="preserve">approval path, and a generated agent gets at most one</a:t>
             </a:r>
             <a:endParaRPr lang="en-US" sz="1200"/>
           </a:p>
@@ -14251,29 +14274,6 @@
             <a:noAutofit/>
           </a:bodyPr>
           <a:lstStyle/>
-          <a:p>
-            <a:pPr marL="0" indent="0">
-              <a:lnSpc>
-                <a:spcPts val="1575"/>
-              </a:lnSpc>
-              <a:spcAft>
-                <a:spcPts val="0"/>
-              </a:spcAft>
-              <a:buNone/>
-            </a:pPr>
-            <a:r>
-              <a:rPr lang="en-US" sz="1200" b="0">
-                <a:solidFill>
-                  <a:srgbClr val="202B33"/>
-                </a:solidFill>
-                <a:latin typeface="Arial"/>
-                <a:ea typeface="Arial"/>
-                <a:cs typeface="Arial"/>
-              </a:rPr>
-              <a:t xml:space="preserve">approval path, and a generated agent gets at most one</a:t>
-            </a:r>
-            <a:endParaRPr lang="en-US" sz="1200"/>
-          </a:p>
           <a:p>
             <a:pPr marL="0" indent="0">
               <a:lnSpc>
@@ -16558,6 +16558,52 @@
             </a:r>
             <a:endParaRPr lang="en-US" sz="1200"/>
           </a:p>
+          <a:p>
+            <a:pPr marL="0" indent="0">
+              <a:lnSpc>
+                <a:spcPts val="1575"/>
+              </a:lnSpc>
+              <a:spcAft>
+                <a:spcPts val="0"/>
+              </a:spcAft>
+              <a:buNone/>
+            </a:pPr>
+            <a:r>
+              <a:rPr lang="en-US" sz="1200" b="0">
+                <a:solidFill>
+                  <a:srgbClr val="202B33"/>
+                </a:solidFill>
+                <a:latin typeface="Arial"/>
+                <a:ea typeface="Arial"/>
+                <a:cs typeface="Arial"/>
+              </a:rPr>
+              <a:t xml:space="preserve">the job continues for matching records.</a:t>
+            </a:r>
+            <a:endParaRPr lang="en-US" sz="1200"/>
+          </a:p>
+          <a:p>
+            <a:pPr marL="0" indent="0">
+              <a:lnSpc>
+                <a:spcPts val="1575"/>
+              </a:lnSpc>
+              <a:spcAft>
+                <a:spcPts val="0"/>
+              </a:spcAft>
+              <a:buNone/>
+            </a:pPr>
+            <a:r>
+              <a:rPr lang="en-US" sz="1200" b="0">
+                <a:solidFill>
+                  <a:srgbClr val="202B33"/>
+                </a:solidFill>
+                <a:latin typeface="Arial"/>
+                <a:ea typeface="Arial"/>
+                <a:cs typeface="Arial"/>
+              </a:rPr>
+              <a:t xml:space="preserve"/>
+            </a:r>
+            <a:endParaRPr lang="en-US" sz="1200"/>
+          </a:p>
         </p:txBody>
       </p:sp>
       <p:sp>
@@ -16603,7 +16649,7 @@
                 <a:ea typeface="Arial"/>
                 <a:cs typeface="Arial"/>
               </a:rPr>
-              <a:t xml:space="preserve">the job continues for matching records.</a:t>
+              <a:t xml:space="preserve">The status change has no semantic evidence. The job</a:t>
             </a:r>
             <a:endParaRPr lang="en-US" sz="1200"/>
           </a:p>
@@ -16626,7 +16672,7 @@
                 <a:ea typeface="Arial"/>
                 <a:cs typeface="Arial"/>
               </a:rPr>
-              <a:t xml:space="preserve"/>
+              <a:t xml:space="preserve">isolates affected records, reports what is</a:t>
             </a:r>
             <a:endParaRPr lang="en-US" sz="1200"/>
           </a:p>
@@ -16649,7 +16695,7 @@
                 <a:ea typeface="Arial"/>
                 <a:cs typeface="Arial"/>
               </a:rPr>
-              <a:t xml:space="preserve">The status change has no semantic evidence. The job</a:t>
+              <a:t xml:space="preserve">incomplete, and hands an owner the samples and the</a:t>
             </a:r>
             <a:endParaRPr lang="en-US" sz="1200"/>
           </a:p>
@@ -16672,7 +16718,7 @@
                 <a:ea typeface="Arial"/>
                 <a:cs typeface="Arial"/>
               </a:rPr>
-              <a:t xml:space="preserve">isolates affected records, reports what is</a:t>
+              <a:t xml:space="preserve">exact question.</a:t>
             </a:r>
             <a:endParaRPr lang="en-US" sz="1200"/>
           </a:p>
@@ -16695,7 +16741,7 @@
                 <a:ea typeface="Arial"/>
                 <a:cs typeface="Arial"/>
               </a:rPr>
-              <a:t xml:space="preserve">incomplete, and hands an owner the samples and the</a:t>
+              <a:t xml:space="preserve"/>
             </a:r>
             <a:endParaRPr lang="en-US" sz="1200"/>
           </a:p>
@@ -16718,7 +16764,7 @@
                 <a:ea typeface="Arial"/>
                 <a:cs typeface="Arial"/>
               </a:rPr>
-              <a:t xml:space="preserve">exact question.</a:t>
+              <a:t xml:space="preserve">The provider timeout has an uncertain outcome. The</a:t>
             </a:r>
             <a:endParaRPr lang="en-US" sz="1200"/>
           </a:p>
@@ -16741,7 +16787,7 @@
                 <a:ea typeface="Arial"/>
                 <a:cs typeface="Arial"/>
               </a:rPr>
-              <a:t xml:space="preserve"/>
+              <a:t xml:space="preserve">controller queries the saved job ID instead of</a:t>
             </a:r>
             <a:endParaRPr lang="en-US" sz="1200"/>
           </a:p>
@@ -16764,7 +16810,7 @@
                 <a:ea typeface="Arial"/>
                 <a:cs typeface="Arial"/>
               </a:rPr>
-              <a:t xml:space="preserve">The provider timeout has an uncertain outcome. The</a:t>
+              <a:t xml:space="preserve">submitting again, and where it cannot, it holds the</a:t>
             </a:r>
             <a:endParaRPr lang="en-US" sz="1200"/>
           </a:p>
@@ -16787,7 +16833,7 @@
                 <a:ea typeface="Arial"/>
                 <a:cs typeface="Arial"/>
               </a:rPr>
-              <a:t xml:space="preserve">controller queries the saved job ID instead of</a:t>
+              <a:t xml:space="preserve">unresolved operation and its reservation.</a:t>
             </a:r>
             <a:endParaRPr lang="en-US" sz="1200"/>
           </a:p>
@@ -16810,7 +16856,7 @@
                 <a:ea typeface="Arial"/>
                 <a:cs typeface="Arial"/>
               </a:rPr>
-              <a:t xml:space="preserve">submitting again, and where it cannot, it holds the</a:t>
+              <a:t xml:space="preserve"/>
             </a:r>
             <a:endParaRPr lang="en-US" sz="1200"/>
           </a:p>
@@ -16833,7 +16879,53 @@
                 <a:ea typeface="Arial"/>
                 <a:cs typeface="Arial"/>
               </a:rPr>
-              <a:t xml:space="preserve">unresolved operation and its reservation.</a:t>
+              <a:t xml:space="preserve">Three events, three different right answers, none of</a:t>
+            </a:r>
+            <a:endParaRPr lang="en-US" sz="1200"/>
+          </a:p>
+          <a:p>
+            <a:pPr marL="0" indent="0">
+              <a:lnSpc>
+                <a:spcPts val="1575"/>
+              </a:lnSpc>
+              <a:spcAft>
+                <a:spcPts val="0"/>
+              </a:spcAft>
+              <a:buNone/>
+            </a:pPr>
+            <a:r>
+              <a:rPr lang="en-US" sz="1200" b="0">
+                <a:solidFill>
+                  <a:srgbClr val="202B33"/>
+                </a:solidFill>
+                <a:latin typeface="Arial"/>
+                <a:ea typeface="Arial"/>
+                <a:cs typeface="Arial"/>
+              </a:rPr>
+              <a:t xml:space="preserve">them success or failure. If your dashboard only has</a:t>
+            </a:r>
+            <a:endParaRPr lang="en-US" sz="1200"/>
+          </a:p>
+          <a:p>
+            <a:pPr marL="0" indent="0">
+              <a:lnSpc>
+                <a:spcPts val="1575"/>
+              </a:lnSpc>
+              <a:spcAft>
+                <a:spcPts val="0"/>
+              </a:spcAft>
+              <a:buNone/>
+            </a:pPr>
+            <a:r>
+              <a:rPr lang="en-US" sz="1200" b="0">
+                <a:solidFill>
+                  <a:srgbClr val="202B33"/>
+                </a:solidFill>
+                <a:latin typeface="Arial"/>
+                <a:ea typeface="Arial"/>
+                <a:cs typeface="Arial"/>
+              </a:rPr>
+              <a:t xml:space="preserve">two states, it is hiding the most interesting one.</a:t>
             </a:r>
             <a:endParaRPr lang="en-US" sz="1200"/>
           </a:p>

</xml_diff>

<commit_message>
Add new presentation on retrieval methods by Dan Levy
</commit_message>
<xml_diff>
--- a/artifacts/speaking-portfolio-expanded/decks/adaptive-systems-15min-handout.pptx
+++ b/artifacts/speaking-portfolio-expanded/decks/adaptive-systems-15min-handout.pptx
@@ -1177,7 +1177,7 @@
                 <a:ea typeface="Arial"/>
                 <a:cs typeface="Arial"/>
               </a:rPr>
-              <a:t xml:space="preserve">So here is the hazard, and it applies to the small systems too. Risk does not grow with the number of tools. It grows with the number of pathways between them, and every integration multiplies those. Ten tools is forty-five pairs before you count chains. Plug in one SaaS with a dozen endpoints and you did not add twelve capabilities; you added hundreds of routes from something the agent can read to something it can do. Nobody reviews those combinations. Not your security team, not the model, not you at three in the morning. The dangerous pairing is never on the roadmap. It gets discovered.</a:t>
+              <a:t xml:space="preserve">Here is the hazard, and it applies to the small systems too. Risk does not grow with the number of tools. It grows with the pathways between them, and every integration multiplies those. Ten tools is forty-five pairs before you count chains. Plug in one SaaS with a dozen endpoints and you did not add twelve capabilities; you added hundreds of routes from something the agent can read to something it can do. Nobody reviews those combinations. Not your security team, not the model, not you at three in the morning. The dangerous pairing is never on the roadmap. It gets discovered.</a:t>
             </a:r>
             <a:endParaRPr lang="en-US" sz="1200"/>
           </a:p>
@@ -1223,7 +1223,7 @@
                 <a:ea typeface="Arial"/>
                 <a:cs typeface="Arial"/>
               </a:rPr>
-              <a:t xml:space="preserve">So the question is not whether to give the assistant access. It is how to keep the number of live pathways small enough to reason about, one job at a time. That is what the rest of this talk builds. The big assistant still exists. It just never has all of its hands full at once: it conjures a small agent per job, with exactly enough.</a:t>
+              <a:t xml:space="preserve">So the question is not whether to grant access. It is how many pathways are live at once. The big assistant still exists; it just never has all of its hands full at the same time, because it conjures a small agent per job with exactly enough.</a:t>
             </a:r>
             <a:endParaRPr lang="en-US" sz="1200"/>
           </a:p>
@@ -1704,7 +1704,7 @@
                 <a:ea typeface="Arial"/>
                 <a:cs typeface="Arial"/>
               </a:rPr>
-              <a:t xml:space="preserve">So here is the hazard, and it applies to the small systems too. Risk does not grow with the number of tools. It grows with the number of pathways between them, and every integration multiplies those. Ten tools is forty-five pairs before you count chains. Plug in one SaaS with a dozen endpoints and you did not add twelve capabilities; you added hundreds of routes from something the agent can read to something it can do. Nobody reviews those combinations. Not your security team, not the model, not you at three in the morning. The dangerous pairing is never on the roadmap. It gets discovered.</a:t>
+              <a:t xml:space="preserve">Here is the hazard, and it applies to the small systems too. Risk does not grow with the number of tools. It grows with the pathways between them, and every integration multiplies those. Ten tools is forty-five pairs before you count chains. Plug in one SaaS with a dozen endpoints and you did not add twelve capabilities; you added hundreds of routes from something the agent can read to something it can do. Nobody reviews those combinations. Not your security team, not the model, not you at three in the morning. The dangerous pairing is never on the roadmap. It gets discovered.</a:t>
             </a:r>
             <a:endParaRPr lang="en-US" sz="1200"/>
           </a:p>
@@ -1750,7 +1750,7 @@
                 <a:ea typeface="Arial"/>
                 <a:cs typeface="Arial"/>
               </a:rPr>
-              <a:t xml:space="preserve">So the question is not whether to give the assistant access. It is how to keep the number of live pathways small enough to reason about, one job at a time. That is what the rest of this talk builds. The big assistant still exists. It just never has all of its hands full at once: it conjures a small agent per job, with exactly enough.</a:t>
+              <a:t xml:space="preserve">So the question is not whether to grant access. It is how many pathways are live at once. The big assistant still exists; it just never has all of its hands full at the same time, because it conjures a small agent per job with exactly enough.</a:t>
             </a:r>
             <a:endParaRPr lang="en-US" sz="1200"/>
           </a:p>
@@ -4201,7 +4201,7 @@
                 <a:ea typeface="Arial"/>
                 <a:cs typeface="Arial"/>
               </a:rPr>
-              <a:t xml:space="preserve">And return to the assistant with everything. It is still coming; nothing on these slides stops it, and I would not want to. What changed is how many of its pathways are live at once. Each job gets a small agent with a tailored prompt, a short tool list, a hard budget, and a log of every time it asked for more. That is the strategy I believe in for the next few years: not one agent holding every combination, which nobody can check, but many small ones you can afford to.</a:t>
+              <a:t xml:space="preserve">And return to the assistant with everything. It is still coming; nothing on these slides stops it, and I would not want them to. What changed is how many of its pathways are live at once. Not one agent holding every combination, which nobody can check. Many small ones you can afford to.</a:t>
             </a:r>
             <a:endParaRPr lang="en-US" sz="1200"/>
           </a:p>
@@ -6704,7 +6704,7 @@
                 <a:ea typeface="Arial"/>
                 <a:cs typeface="Arial"/>
               </a:rPr>
-              <a:t xml:space="preserve">So here is the hazard, and it applies to the small</a:t>
+              <a:t xml:space="preserve">Here is the hazard, and it applies to the small</a:t>
             </a:r>
             <a:endParaRPr lang="en-US" sz="1200"/>
           </a:p>
@@ -6750,191 +6750,191 @@
                 <a:ea typeface="Arial"/>
                 <a:cs typeface="Arial"/>
               </a:rPr>
-              <a:t xml:space="preserve">tools. It grows with the number of pathways between</a:t>
-            </a:r>
-            <a:endParaRPr lang="en-US" sz="1200"/>
-          </a:p>
-          <a:p>
-            <a:pPr marL="0" indent="0">
-              <a:lnSpc>
-                <a:spcPts val="1575"/>
-              </a:lnSpc>
-              <a:spcAft>
-                <a:spcPts val="0"/>
-              </a:spcAft>
-              <a:buNone/>
-            </a:pPr>
-            <a:r>
-              <a:rPr lang="en-US" sz="1200" b="0">
-                <a:solidFill>
-                  <a:srgbClr val="202B33"/>
-                </a:solidFill>
-                <a:latin typeface="Arial"/>
-                <a:ea typeface="Arial"/>
-                <a:cs typeface="Arial"/>
-              </a:rPr>
-              <a:t xml:space="preserve">them, and every integration multiplies those. Ten</a:t>
-            </a:r>
-            <a:endParaRPr lang="en-US" sz="1200"/>
-          </a:p>
-          <a:p>
-            <a:pPr marL="0" indent="0">
-              <a:lnSpc>
-                <a:spcPts val="1575"/>
-              </a:lnSpc>
-              <a:spcAft>
-                <a:spcPts val="0"/>
-              </a:spcAft>
-              <a:buNone/>
-            </a:pPr>
-            <a:r>
-              <a:rPr lang="en-US" sz="1200" b="0">
-                <a:solidFill>
-                  <a:srgbClr val="202B33"/>
-                </a:solidFill>
-                <a:latin typeface="Arial"/>
-                <a:ea typeface="Arial"/>
-                <a:cs typeface="Arial"/>
-              </a:rPr>
-              <a:t xml:space="preserve">tools is forty-five pairs before you count chains.</a:t>
-            </a:r>
-            <a:endParaRPr lang="en-US" sz="1200"/>
-          </a:p>
-          <a:p>
-            <a:pPr marL="0" indent="0">
-              <a:lnSpc>
-                <a:spcPts val="1575"/>
-              </a:lnSpc>
-              <a:spcAft>
-                <a:spcPts val="0"/>
-              </a:spcAft>
-              <a:buNone/>
-            </a:pPr>
-            <a:r>
-              <a:rPr lang="en-US" sz="1200" b="0">
-                <a:solidFill>
-                  <a:srgbClr val="202B33"/>
-                </a:solidFill>
-                <a:latin typeface="Arial"/>
-                <a:ea typeface="Arial"/>
-                <a:cs typeface="Arial"/>
-              </a:rPr>
-              <a:t xml:space="preserve">Plug in one SaaS with a dozen endpoints and you did</a:t>
-            </a:r>
-            <a:endParaRPr lang="en-US" sz="1200"/>
-          </a:p>
-          <a:p>
-            <a:pPr marL="0" indent="0">
-              <a:lnSpc>
-                <a:spcPts val="1575"/>
-              </a:lnSpc>
-              <a:spcAft>
-                <a:spcPts val="0"/>
-              </a:spcAft>
-              <a:buNone/>
-            </a:pPr>
-            <a:r>
-              <a:rPr lang="en-US" sz="1200" b="0">
-                <a:solidFill>
-                  <a:srgbClr val="202B33"/>
-                </a:solidFill>
-                <a:latin typeface="Arial"/>
-                <a:ea typeface="Arial"/>
-                <a:cs typeface="Arial"/>
-              </a:rPr>
-              <a:t xml:space="preserve">not add twelve capabilities; you added hundreds of</a:t>
-            </a:r>
-            <a:endParaRPr lang="en-US" sz="1200"/>
-          </a:p>
-          <a:p>
-            <a:pPr marL="0" indent="0">
-              <a:lnSpc>
-                <a:spcPts val="1575"/>
-              </a:lnSpc>
-              <a:spcAft>
-                <a:spcPts val="0"/>
-              </a:spcAft>
-              <a:buNone/>
-            </a:pPr>
-            <a:r>
-              <a:rPr lang="en-US" sz="1200" b="0">
-                <a:solidFill>
-                  <a:srgbClr val="202B33"/>
-                </a:solidFill>
-                <a:latin typeface="Arial"/>
-                <a:ea typeface="Arial"/>
-                <a:cs typeface="Arial"/>
-              </a:rPr>
-              <a:t xml:space="preserve">routes from something the agent can read to something</a:t>
-            </a:r>
-            <a:endParaRPr lang="en-US" sz="1200"/>
-          </a:p>
-          <a:p>
-            <a:pPr marL="0" indent="0">
-              <a:lnSpc>
-                <a:spcPts val="1575"/>
-              </a:lnSpc>
-              <a:spcAft>
-                <a:spcPts val="0"/>
-              </a:spcAft>
-              <a:buNone/>
-            </a:pPr>
-            <a:r>
-              <a:rPr lang="en-US" sz="1200" b="0">
-                <a:solidFill>
-                  <a:srgbClr val="202B33"/>
-                </a:solidFill>
-                <a:latin typeface="Arial"/>
-                <a:ea typeface="Arial"/>
-                <a:cs typeface="Arial"/>
-              </a:rPr>
-              <a:t xml:space="preserve">it can do. Nobody reviews those combinations. Not</a:t>
-            </a:r>
-            <a:endParaRPr lang="en-US" sz="1200"/>
-          </a:p>
-          <a:p>
-            <a:pPr marL="0" indent="0">
-              <a:lnSpc>
-                <a:spcPts val="1575"/>
-              </a:lnSpc>
-              <a:spcAft>
-                <a:spcPts val="0"/>
-              </a:spcAft>
-              <a:buNone/>
-            </a:pPr>
-            <a:r>
-              <a:rPr lang="en-US" sz="1200" b="0">
-                <a:solidFill>
-                  <a:srgbClr val="202B33"/>
-                </a:solidFill>
-                <a:latin typeface="Arial"/>
-                <a:ea typeface="Arial"/>
-                <a:cs typeface="Arial"/>
-              </a:rPr>
-              <a:t xml:space="preserve">your security team, not the model, not you at three</a:t>
-            </a:r>
-            <a:endParaRPr lang="en-US" sz="1200"/>
-          </a:p>
-          <a:p>
-            <a:pPr marL="0" indent="0">
-              <a:lnSpc>
-                <a:spcPts val="1575"/>
-              </a:lnSpc>
-              <a:spcAft>
-                <a:spcPts val="0"/>
-              </a:spcAft>
-              <a:buNone/>
-            </a:pPr>
-            <a:r>
-              <a:rPr lang="en-US" sz="1200" b="0">
-                <a:solidFill>
-                  <a:srgbClr val="202B33"/>
-                </a:solidFill>
-                <a:latin typeface="Arial"/>
-                <a:ea typeface="Arial"/>
-                <a:cs typeface="Arial"/>
-              </a:rPr>
-              <a:t xml:space="preserve">in the morning. The dangerous pairing is never on the</a:t>
+              <a:t xml:space="preserve">tools. It grows with the pathways between them, and</a:t>
+            </a:r>
+            <a:endParaRPr lang="en-US" sz="1200"/>
+          </a:p>
+          <a:p>
+            <a:pPr marL="0" indent="0">
+              <a:lnSpc>
+                <a:spcPts val="1575"/>
+              </a:lnSpc>
+              <a:spcAft>
+                <a:spcPts val="0"/>
+              </a:spcAft>
+              <a:buNone/>
+            </a:pPr>
+            <a:r>
+              <a:rPr lang="en-US" sz="1200" b="0">
+                <a:solidFill>
+                  <a:srgbClr val="202B33"/>
+                </a:solidFill>
+                <a:latin typeface="Arial"/>
+                <a:ea typeface="Arial"/>
+                <a:cs typeface="Arial"/>
+              </a:rPr>
+              <a:t xml:space="preserve">every integration multiplies those. Ten tools is</a:t>
+            </a:r>
+            <a:endParaRPr lang="en-US" sz="1200"/>
+          </a:p>
+          <a:p>
+            <a:pPr marL="0" indent="0">
+              <a:lnSpc>
+                <a:spcPts val="1575"/>
+              </a:lnSpc>
+              <a:spcAft>
+                <a:spcPts val="0"/>
+              </a:spcAft>
+              <a:buNone/>
+            </a:pPr>
+            <a:r>
+              <a:rPr lang="en-US" sz="1200" b="0">
+                <a:solidFill>
+                  <a:srgbClr val="202B33"/>
+                </a:solidFill>
+                <a:latin typeface="Arial"/>
+                <a:ea typeface="Arial"/>
+                <a:cs typeface="Arial"/>
+              </a:rPr>
+              <a:t xml:space="preserve">forty-five pairs before you count chains. Plug in one</a:t>
+            </a:r>
+            <a:endParaRPr lang="en-US" sz="1200"/>
+          </a:p>
+          <a:p>
+            <a:pPr marL="0" indent="0">
+              <a:lnSpc>
+                <a:spcPts val="1575"/>
+              </a:lnSpc>
+              <a:spcAft>
+                <a:spcPts val="0"/>
+              </a:spcAft>
+              <a:buNone/>
+            </a:pPr>
+            <a:r>
+              <a:rPr lang="en-US" sz="1200" b="0">
+                <a:solidFill>
+                  <a:srgbClr val="202B33"/>
+                </a:solidFill>
+                <a:latin typeface="Arial"/>
+                <a:ea typeface="Arial"/>
+                <a:cs typeface="Arial"/>
+              </a:rPr>
+              <a:t xml:space="preserve">SaaS with a dozen endpoints and you did not add</a:t>
+            </a:r>
+            <a:endParaRPr lang="en-US" sz="1200"/>
+          </a:p>
+          <a:p>
+            <a:pPr marL="0" indent="0">
+              <a:lnSpc>
+                <a:spcPts val="1575"/>
+              </a:lnSpc>
+              <a:spcAft>
+                <a:spcPts val="0"/>
+              </a:spcAft>
+              <a:buNone/>
+            </a:pPr>
+            <a:r>
+              <a:rPr lang="en-US" sz="1200" b="0">
+                <a:solidFill>
+                  <a:srgbClr val="202B33"/>
+                </a:solidFill>
+                <a:latin typeface="Arial"/>
+                <a:ea typeface="Arial"/>
+                <a:cs typeface="Arial"/>
+              </a:rPr>
+              <a:t xml:space="preserve">twelve capabilities; you added hundreds of routes</a:t>
+            </a:r>
+            <a:endParaRPr lang="en-US" sz="1200"/>
+          </a:p>
+          <a:p>
+            <a:pPr marL="0" indent="0">
+              <a:lnSpc>
+                <a:spcPts val="1575"/>
+              </a:lnSpc>
+              <a:spcAft>
+                <a:spcPts val="0"/>
+              </a:spcAft>
+              <a:buNone/>
+            </a:pPr>
+            <a:r>
+              <a:rPr lang="en-US" sz="1200" b="0">
+                <a:solidFill>
+                  <a:srgbClr val="202B33"/>
+                </a:solidFill>
+                <a:latin typeface="Arial"/>
+                <a:ea typeface="Arial"/>
+                <a:cs typeface="Arial"/>
+              </a:rPr>
+              <a:t xml:space="preserve">from something the agent can read to something it can</a:t>
+            </a:r>
+            <a:endParaRPr lang="en-US" sz="1200"/>
+          </a:p>
+          <a:p>
+            <a:pPr marL="0" indent="0">
+              <a:lnSpc>
+                <a:spcPts val="1575"/>
+              </a:lnSpc>
+              <a:spcAft>
+                <a:spcPts val="0"/>
+              </a:spcAft>
+              <a:buNone/>
+            </a:pPr>
+            <a:r>
+              <a:rPr lang="en-US" sz="1200" b="0">
+                <a:solidFill>
+                  <a:srgbClr val="202B33"/>
+                </a:solidFill>
+                <a:latin typeface="Arial"/>
+                <a:ea typeface="Arial"/>
+                <a:cs typeface="Arial"/>
+              </a:rPr>
+              <a:t xml:space="preserve">do. Nobody reviews those combinations. Not your</a:t>
+            </a:r>
+            <a:endParaRPr lang="en-US" sz="1200"/>
+          </a:p>
+          <a:p>
+            <a:pPr marL="0" indent="0">
+              <a:lnSpc>
+                <a:spcPts val="1575"/>
+              </a:lnSpc>
+              <a:spcAft>
+                <a:spcPts val="0"/>
+              </a:spcAft>
+              <a:buNone/>
+            </a:pPr>
+            <a:r>
+              <a:rPr lang="en-US" sz="1200" b="0">
+                <a:solidFill>
+                  <a:srgbClr val="202B33"/>
+                </a:solidFill>
+                <a:latin typeface="Arial"/>
+                <a:ea typeface="Arial"/>
+                <a:cs typeface="Arial"/>
+              </a:rPr>
+              <a:t xml:space="preserve">security team, not the model, not you at three in the</a:t>
+            </a:r>
+            <a:endParaRPr lang="en-US" sz="1200"/>
+          </a:p>
+          <a:p>
+            <a:pPr marL="0" indent="0">
+              <a:lnSpc>
+                <a:spcPts val="1575"/>
+              </a:lnSpc>
+              <a:spcAft>
+                <a:spcPts val="0"/>
+              </a:spcAft>
+              <a:buNone/>
+            </a:pPr>
+            <a:r>
+              <a:rPr lang="en-US" sz="1200" b="0">
+                <a:solidFill>
+                  <a:srgbClr val="202B33"/>
+                </a:solidFill>
+                <a:latin typeface="Arial"/>
+                <a:ea typeface="Arial"/>
+                <a:cs typeface="Arial"/>
+              </a:rPr>
+              <a:t xml:space="preserve">morning. The dangerous pairing is never on the</a:t>
             </a:r>
             <a:endParaRPr lang="en-US" sz="1200"/>
           </a:p>
@@ -7235,7 +7235,7 @@
                 <a:ea typeface="Arial"/>
                 <a:cs typeface="Arial"/>
               </a:rPr>
-              <a:t xml:space="preserve">So the question is not whether to give the</a:t>
+              <a:t xml:space="preserve">So the question is not whether to grant</a:t>
             </a:r>
             <a:endParaRPr lang="en-US" sz="1500"/>
           </a:p>
@@ -7258,7 +7258,7 @@
                 <a:ea typeface="Arial"/>
                 <a:cs typeface="Arial"/>
               </a:rPr>
-              <a:t xml:space="preserve">assistant access. It is how to keep the</a:t>
+              <a:t xml:space="preserve">access. It is how many pathways are live at</a:t>
             </a:r>
             <a:endParaRPr lang="en-US" sz="1500"/>
           </a:p>
@@ -7281,30 +7281,7 @@
                 <a:ea typeface="Arial"/>
                 <a:cs typeface="Arial"/>
               </a:rPr>
-              <a:t xml:space="preserve">number of live pathways small enough to</a:t>
-            </a:r>
-            <a:endParaRPr lang="en-US" sz="1500"/>
-          </a:p>
-          <a:p>
-            <a:pPr marL="0" indent="0">
-              <a:lnSpc>
-                <a:spcPts val="1950"/>
-              </a:lnSpc>
-              <a:spcAft>
-                <a:spcPts val="0"/>
-              </a:spcAft>
-              <a:buNone/>
-            </a:pPr>
-            <a:r>
-              <a:rPr lang="en-US" sz="1500" b="0">
-                <a:solidFill>
-                  <a:srgbClr val="202B33"/>
-                </a:solidFill>
-                <a:latin typeface="Arial"/>
-                <a:ea typeface="Arial"/>
-                <a:cs typeface="Arial"/>
-              </a:rPr>
-              <a:t xml:space="preserve">reason about, one job at a time. That is</a:t>
+              <a:t xml:space="preserve">once. The big assistant still exists; it</a:t>
             </a:r>
             <a:endParaRPr lang="en-US" sz="1500"/>
           </a:p>
@@ -7353,7 +7330,7 @@
                 <a:ea typeface="Arial"/>
                 <a:cs typeface="Arial"/>
               </a:rPr>
-              <a:t xml:space="preserve">what the rest of this talk builds. The big</a:t>
+              <a:t xml:space="preserve">just never has all of its hands full at the</a:t>
             </a:r>
             <a:endParaRPr lang="en-US" sz="1500"/>
           </a:p>
@@ -7376,7 +7353,7 @@
                 <a:ea typeface="Arial"/>
                 <a:cs typeface="Arial"/>
               </a:rPr>
-              <a:t xml:space="preserve">assistant still exists. It just never has</a:t>
+              <a:t xml:space="preserve">same time, because it conjures a small</a:t>
             </a:r>
             <a:endParaRPr lang="en-US" sz="1500"/>
           </a:p>
@@ -7399,30 +7376,7 @@
                 <a:ea typeface="Arial"/>
                 <a:cs typeface="Arial"/>
               </a:rPr>
-              <a:t xml:space="preserve">all of its hands full at once: it conjures</a:t>
-            </a:r>
-            <a:endParaRPr lang="en-US" sz="1500"/>
-          </a:p>
-          <a:p>
-            <a:pPr marL="0" indent="0">
-              <a:lnSpc>
-                <a:spcPts val="1950"/>
-              </a:lnSpc>
-              <a:spcAft>
-                <a:spcPts val="0"/>
-              </a:spcAft>
-              <a:buNone/>
-            </a:pPr>
-            <a:r>
-              <a:rPr lang="en-US" sz="1500" b="0">
-                <a:solidFill>
-                  <a:srgbClr val="202B33"/>
-                </a:solidFill>
-                <a:latin typeface="Arial"/>
-                <a:ea typeface="Arial"/>
-                <a:cs typeface="Arial"/>
-              </a:rPr>
-              <a:t xml:space="preserve">a small agent per job, with exactly enough.</a:t>
+              <a:t xml:space="preserve">agent per job with exactly enough.</a:t>
             </a:r>
             <a:endParaRPr lang="en-US" sz="1500"/>
           </a:p>
@@ -11137,7 +11091,7 @@
                 <a:ea typeface="Arial"/>
                 <a:cs typeface="Arial"/>
               </a:rPr>
-              <a:t xml:space="preserve">to. What changed is how many of its</a:t>
+              <a:t xml:space="preserve">them to. What changed is how many of its</a:t>
             </a:r>
             <a:endParaRPr lang="en-US" sz="1500"/>
           </a:p>
@@ -11160,7 +11114,7 @@
                 <a:ea typeface="Arial"/>
                 <a:cs typeface="Arial"/>
               </a:rPr>
-              <a:t xml:space="preserve">pathways are live at once. Each job gets a</a:t>
+              <a:t xml:space="preserve">pathways are live at once. Not one agent</a:t>
             </a:r>
             <a:endParaRPr lang="en-US" sz="1500"/>
           </a:p>
@@ -11183,76 +11137,7 @@
                 <a:ea typeface="Arial"/>
                 <a:cs typeface="Arial"/>
               </a:rPr>
-              <a:t xml:space="preserve">small agent with a tailored prompt, a short</a:t>
-            </a:r>
-            <a:endParaRPr lang="en-US" sz="1500"/>
-          </a:p>
-          <a:p>
-            <a:pPr marL="0" indent="0">
-              <a:lnSpc>
-                <a:spcPts val="1950"/>
-              </a:lnSpc>
-              <a:spcAft>
-                <a:spcPts val="0"/>
-              </a:spcAft>
-              <a:buNone/>
-            </a:pPr>
-            <a:r>
-              <a:rPr lang="en-US" sz="1500" b="0">
-                <a:solidFill>
-                  <a:srgbClr val="202B33"/>
-                </a:solidFill>
-                <a:latin typeface="Arial"/>
-                <a:ea typeface="Arial"/>
-                <a:cs typeface="Arial"/>
-              </a:rPr>
-              <a:t xml:space="preserve">tool list, a hard budget, and a log of</a:t>
-            </a:r>
-            <a:endParaRPr lang="en-US" sz="1500"/>
-          </a:p>
-          <a:p>
-            <a:pPr marL="0" indent="0">
-              <a:lnSpc>
-                <a:spcPts val="1950"/>
-              </a:lnSpc>
-              <a:spcAft>
-                <a:spcPts val="0"/>
-              </a:spcAft>
-              <a:buNone/>
-            </a:pPr>
-            <a:r>
-              <a:rPr lang="en-US" sz="1500" b="0">
-                <a:solidFill>
-                  <a:srgbClr val="202B33"/>
-                </a:solidFill>
-                <a:latin typeface="Arial"/>
-                <a:ea typeface="Arial"/>
-                <a:cs typeface="Arial"/>
-              </a:rPr>
-              <a:t xml:space="preserve">every time it asked for more. That is the</a:t>
-            </a:r>
-            <a:endParaRPr lang="en-US" sz="1500"/>
-          </a:p>
-          <a:p>
-            <a:pPr marL="0" indent="0">
-              <a:lnSpc>
-                <a:spcPts val="1950"/>
-              </a:lnSpc>
-              <a:spcAft>
-                <a:spcPts val="0"/>
-              </a:spcAft>
-              <a:buNone/>
-            </a:pPr>
-            <a:r>
-              <a:rPr lang="en-US" sz="1500" b="0">
-                <a:solidFill>
-                  <a:srgbClr val="202B33"/>
-                </a:solidFill>
-                <a:latin typeface="Arial"/>
-                <a:ea typeface="Arial"/>
-                <a:cs typeface="Arial"/>
-              </a:rPr>
-              <a:t xml:space="preserve">strategy I believe in for the next few</a:t>
+              <a:t xml:space="preserve">holding every combination, which nobody can</a:t>
             </a:r>
             <a:endParaRPr lang="en-US" sz="1500"/>
           </a:p>
@@ -11301,53 +11186,7 @@
                 <a:ea typeface="Arial"/>
                 <a:cs typeface="Arial"/>
               </a:rPr>
-              <a:t xml:space="preserve">years: not one agent holding every</a:t>
-            </a:r>
-            <a:endParaRPr lang="en-US" sz="1500"/>
-          </a:p>
-          <a:p>
-            <a:pPr marL="0" indent="0">
-              <a:lnSpc>
-                <a:spcPts val="1950"/>
-              </a:lnSpc>
-              <a:spcAft>
-                <a:spcPts val="0"/>
-              </a:spcAft>
-              <a:buNone/>
-            </a:pPr>
-            <a:r>
-              <a:rPr lang="en-US" sz="1500" b="0">
-                <a:solidFill>
-                  <a:srgbClr val="202B33"/>
-                </a:solidFill>
-                <a:latin typeface="Arial"/>
-                <a:ea typeface="Arial"/>
-                <a:cs typeface="Arial"/>
-              </a:rPr>
-              <a:t xml:space="preserve">combination, which nobody can check, but</a:t>
-            </a:r>
-            <a:endParaRPr lang="en-US" sz="1500"/>
-          </a:p>
-          <a:p>
-            <a:pPr marL="0" indent="0">
-              <a:lnSpc>
-                <a:spcPts val="1950"/>
-              </a:lnSpc>
-              <a:spcAft>
-                <a:spcPts val="0"/>
-              </a:spcAft>
-              <a:buNone/>
-            </a:pPr>
-            <a:r>
-              <a:rPr lang="en-US" sz="1500" b="0">
-                <a:solidFill>
-                  <a:srgbClr val="202B33"/>
-                </a:solidFill>
-                <a:latin typeface="Arial"/>
-                <a:ea typeface="Arial"/>
-                <a:cs typeface="Arial"/>
-              </a:rPr>
-              <a:t xml:space="preserve">many small ones you can afford to.</a:t>
+              <a:t xml:space="preserve">check. Many small ones you can afford to.</a:t>
             </a:r>
             <a:endParaRPr lang="en-US" sz="1500"/>
           </a:p>

</xml_diff>